<commit_message>
Add a one-page setup and a ready-to-run close to the deck
The short path is docs/SETUP.md. The slides end on the same five steps
and the three checks that mean the overnight run is ready.

Co-authored-by: MNabikhel <MNabikhel@users.noreply.github.com>
</commit_message>
<xml_diff>
--- a/docs/CloseDesk-how-it-works.pptx
+++ b/docs/CloseDesk-how-it-works.pptx
@@ -17,6 +17,7 @@
     <p:sldId id="265" r:id="rId16"/>
     <p:sldId id="266" r:id="rId17"/>
     <p:sldId id="267" r:id="rId18"/>
+    <p:sldId id="268" r:id="rId19"/>
   </p:sldIdLst>
   <p:sldSz cx="12191695" cy="6858000" type="screen4x3"/>
   <p:notesSz cx="6858000" cy="9144000"/>
@@ -3684,7 +3685,7 @@
                 </a:solidFill>
                 <a:latin typeface="Calibri"/>
               </a:rPr>
-              <a:t>10  /  12</a:t>
+              <a:t>10  /  13</a:t>
             </a:r>
           </a:p>
         </p:txBody>
@@ -4112,7 +4113,7 @@
                 </a:solidFill>
                 <a:latin typeface="Calibri"/>
               </a:rPr>
-              <a:t>11  /  12</a:t>
+              <a:t>11  /  13</a:t>
             </a:r>
           </a:p>
         </p:txBody>
@@ -4251,7 +4252,7 @@
                 </a:solidFill>
                 <a:latin typeface="Calibri"/>
               </a:rPr>
-              <a:t>TONIGHT</a:t>
+              <a:t>EASY SETUP</a:t>
             </a:r>
           </a:p>
         </p:txBody>
@@ -4286,7 +4287,7 @@
                 </a:solidFill>
                 <a:latin typeface="Georgia"/>
               </a:rPr>
-              <a:t>Five steps, then leave it.</a:t>
+              <a:t>Five steps. The written page is docs/SETUP.md.</a:t>
             </a:r>
           </a:p>
         </p:txBody>
@@ -4299,8 +4300,8 @@
         </p:nvSpPr>
         <p:spPr>
           <a:xfrm>
-            <a:off x="502920" y="1600200"/>
-            <a:ext cx="11155680" cy="3291840"/>
+            <a:off x="502920" y="1554480"/>
+            <a:ext cx="11155680" cy="3840480"/>
           </a:xfrm>
           <a:prstGeom prst="rect">
             <a:avLst/>
@@ -4325,7 +4326,7 @@
                 </a:solidFill>
                 <a:latin typeface="Calibri"/>
               </a:rPr>
-              <a:t>1    Install the project and the Python packages.</a:t>
+              <a:t>1    Install.  python -m venv .venv, then pip install -e ".[dev]"</a:t>
             </a:r>
           </a:p>
           <a:p>
@@ -4341,7 +4342,7 @@
                 </a:solidFill>
                 <a:latin typeface="Calibri"/>
               </a:rPr>
-              <a:t>2    Load a model in LM Studio and start the local server.</a:t>
+              <a:t>2    Prove it.  python -m controller_inbox demo --serve</a:t>
             </a:r>
           </a:p>
           <a:p>
@@ -4357,7 +4358,7 @@
                 </a:solidFill>
                 <a:latin typeface="Calibri"/>
               </a:rPr>
-              <a:t>3    Add the closedesk-inbox skill in Bionic, and turn CONTROLLER_INBOX_LLM on.</a:t>
+              <a:t>3    Start LM Studio’s local server, and set CONTROLLER_INBOX_LLM=true</a:t>
             </a:r>
           </a:p>
           <a:p>
@@ -4373,7 +4374,7 @@
                 </a:solidFill>
                 <a:latin typeface="Calibri"/>
               </a:rPr>
-              <a:t>4    Drop today’s .msg files into inbox/incoming.</a:t>
+              <a:t>4    Drop .msg files into inbox/incoming</a:t>
             </a:r>
           </a:p>
           <a:p>
@@ -4389,7 +4390,7 @@
                 </a:solidFill>
                 <a:latin typeface="Calibri"/>
               </a:rPr>
-              <a:t>5    Run python -m controller_inbox overnight. In the morning, open the dashboard.</a:t>
+              <a:t>5    python -m controller_inbox overnight, then serve in the morning</a:t>
             </a:r>
           </a:p>
         </p:txBody>
@@ -4402,8 +4403,8 @@
         </p:nvSpPr>
         <p:spPr>
           <a:xfrm>
-            <a:off x="502920" y="5212080"/>
-            <a:ext cx="10972800" cy="548640"/>
+            <a:off x="502920" y="5623560"/>
+            <a:ext cx="10972800" cy="411480"/>
           </a:xfrm>
           <a:prstGeom prst="rect">
             <a:avLst/>
@@ -4424,7 +4425,7 @@
                 </a:solidFill>
                 <a:latin typeface="Calibri"/>
               </a:rPr>
-              <a:t>Rows marked Waiting on Bionic are drafts. Read by Bionic means the model filed them.</a:t>
+              <a:t>Outlook login is optional. The drop folder is enough for the first night.</a:t>
             </a:r>
           </a:p>
         </p:txBody>
@@ -4494,7 +4495,695 @@
                 </a:solidFill>
                 <a:latin typeface="Calibri"/>
               </a:rPr>
-              <a:t>12  /  12</a:t>
+              <a:t>12  /  13</a:t>
+            </a:r>
+          </a:p>
+        </p:txBody>
+      </p:sp>
+    </p:spTree>
+  </p:cSld>
+  <p:clrMapOvr>
+    <a:masterClrMapping/>
+  </p:clrMapOvr>
+</p:sld>
+</file>
+
+<file path=ppt/slides/slide13.xml><?xml version="1.0" encoding="utf-8"?>
+<p:sld xmlns:a="http://schemas.openxmlformats.org/drawingml/2006/main" xmlns:p="http://schemas.openxmlformats.org/presentationml/2006/main" xmlns:r="http://schemas.openxmlformats.org/officeDocument/2006/relationships">
+  <p:cSld>
+    <p:spTree>
+      <p:nvGrpSpPr>
+        <p:cNvPr id="1" name=""/>
+        <p:cNvGrpSpPr/>
+        <p:nvPr/>
+      </p:nvGrpSpPr>
+      <p:grpSpPr/>
+      <p:sp>
+        <p:nvSpPr>
+          <p:cNvPr id="2" name="Rectangle 1"/>
+          <p:cNvSpPr/>
+          <p:nvPr/>
+        </p:nvSpPr>
+        <p:spPr>
+          <a:xfrm>
+            <a:off x="0" y="0"/>
+            <a:ext cx="12191695" cy="6858000"/>
+          </a:xfrm>
+          <a:prstGeom prst="rect">
+            <a:avLst/>
+          </a:prstGeom>
+          <a:solidFill>
+            <a:srgbClr val="F6F4EF"/>
+          </a:solidFill>
+          <a:ln>
+            <a:noFill/>
+          </a:ln>
+        </p:spPr>
+        <p:style>
+          <a:lnRef idx="1">
+            <a:schemeClr val="accent1"/>
+          </a:lnRef>
+          <a:fillRef idx="3">
+            <a:schemeClr val="accent1"/>
+          </a:fillRef>
+          <a:effectRef idx="2">
+            <a:schemeClr val="accent1"/>
+          </a:effectRef>
+          <a:fontRef idx="minor">
+            <a:schemeClr val="lt1"/>
+          </a:fontRef>
+        </p:style>
+        <p:txBody>
+          <a:bodyPr rtlCol="0" anchor="ctr"/>
+          <a:lstStyle/>
+          <a:p>
+            <a:pPr algn="ctr"/>
+          </a:p>
+        </p:txBody>
+      </p:sp>
+      <p:sp>
+        <p:nvSpPr>
+          <p:cNvPr id="3" name="Rectangle 2"/>
+          <p:cNvSpPr/>
+          <p:nvPr/>
+        </p:nvSpPr>
+        <p:spPr>
+          <a:xfrm>
+            <a:off x="0" y="0"/>
+            <a:ext cx="146304" cy="6858000"/>
+          </a:xfrm>
+          <a:prstGeom prst="rect">
+            <a:avLst/>
+          </a:prstGeom>
+          <a:solidFill>
+            <a:srgbClr val="C4A15A"/>
+          </a:solidFill>
+          <a:ln>
+            <a:noFill/>
+          </a:ln>
+        </p:spPr>
+        <p:style>
+          <a:lnRef idx="1">
+            <a:schemeClr val="accent1"/>
+          </a:lnRef>
+          <a:fillRef idx="3">
+            <a:schemeClr val="accent1"/>
+          </a:fillRef>
+          <a:effectRef idx="2">
+            <a:schemeClr val="accent1"/>
+          </a:effectRef>
+          <a:fontRef idx="minor">
+            <a:schemeClr val="lt1"/>
+          </a:fontRef>
+        </p:style>
+        <p:txBody>
+          <a:bodyPr rtlCol="0" anchor="ctr"/>
+          <a:lstStyle/>
+          <a:p>
+            <a:pPr algn="ctr"/>
+          </a:p>
+        </p:txBody>
+      </p:sp>
+      <p:sp>
+        <p:nvSpPr>
+          <p:cNvPr id="4" name="TextBox 3"/>
+          <p:cNvSpPr txBox="1"/>
+          <p:nvPr/>
+        </p:nvSpPr>
+        <p:spPr>
+          <a:xfrm>
+            <a:off x="502920" y="292608"/>
+            <a:ext cx="10972800" cy="292608"/>
+          </a:xfrm>
+          <a:prstGeom prst="rect">
+            <a:avLst/>
+          </a:prstGeom>
+          <a:noFill/>
+        </p:spPr>
+        <p:txBody>
+          <a:bodyPr wrap="square">
+            <a:spAutoFit/>
+          </a:bodyPr>
+          <a:lstStyle/>
+          <a:p>
+            <a:pPr algn="l"/>
+            <a:r>
+              <a:rPr sz="1200" b="1">
+                <a:solidFill>
+                  <a:srgbClr val="C4A15A"/>
+                </a:solidFill>
+                <a:latin typeface="Calibri"/>
+              </a:rPr>
+              <a:t>READY TO RUN</a:t>
+            </a:r>
+          </a:p>
+        </p:txBody>
+      </p:sp>
+      <p:sp>
+        <p:nvSpPr>
+          <p:cNvPr id="5" name="TextBox 4"/>
+          <p:cNvSpPr txBox="1"/>
+          <p:nvPr/>
+        </p:nvSpPr>
+        <p:spPr>
+          <a:xfrm>
+            <a:off x="502920" y="530352"/>
+            <a:ext cx="11155680" cy="640080"/>
+          </a:xfrm>
+          <a:prstGeom prst="rect">
+            <a:avLst/>
+          </a:prstGeom>
+          <a:noFill/>
+        </p:spPr>
+        <p:txBody>
+          <a:bodyPr wrap="square">
+            <a:spAutoFit/>
+          </a:bodyPr>
+          <a:lstStyle/>
+          <a:p>
+            <a:pPr algn="l"/>
+            <a:r>
+              <a:rPr sz="3200" b="1">
+                <a:solidFill>
+                  <a:srgbClr val="12243F"/>
+                </a:solidFill>
+                <a:latin typeface="Georgia"/>
+              </a:rPr>
+              <a:t>Three checks, then leave it on overnight.</a:t>
+            </a:r>
+          </a:p>
+        </p:txBody>
+      </p:sp>
+      <p:sp>
+        <p:nvSpPr>
+          <p:cNvPr id="6" name="Rectangle 5"/>
+          <p:cNvSpPr/>
+          <p:nvPr/>
+        </p:nvSpPr>
+        <p:spPr>
+          <a:xfrm>
+            <a:off x="502920" y="1554480"/>
+            <a:ext cx="11155680" cy="1188720"/>
+          </a:xfrm>
+          <a:prstGeom prst="rect">
+            <a:avLst/>
+          </a:prstGeom>
+          <a:solidFill>
+            <a:srgbClr val="FFFCF7"/>
+          </a:solidFill>
+          <a:ln>
+            <a:noFill/>
+          </a:ln>
+        </p:spPr>
+        <p:style>
+          <a:lnRef idx="1">
+            <a:schemeClr val="accent1"/>
+          </a:lnRef>
+          <a:fillRef idx="3">
+            <a:schemeClr val="accent1"/>
+          </a:fillRef>
+          <a:effectRef idx="2">
+            <a:schemeClr val="accent1"/>
+          </a:effectRef>
+          <a:fontRef idx="minor">
+            <a:schemeClr val="lt1"/>
+          </a:fontRef>
+        </p:style>
+        <p:txBody>
+          <a:bodyPr rtlCol="0" anchor="ctr"/>
+          <a:lstStyle/>
+          <a:p>
+            <a:pPr algn="ctr"/>
+          </a:p>
+        </p:txBody>
+      </p:sp>
+      <p:sp>
+        <p:nvSpPr>
+          <p:cNvPr id="7" name="TextBox 6"/>
+          <p:cNvSpPr txBox="1"/>
+          <p:nvPr/>
+        </p:nvSpPr>
+        <p:spPr>
+          <a:xfrm>
+            <a:off x="685800" y="1810512"/>
+            <a:ext cx="640080" cy="640080"/>
+          </a:xfrm>
+          <a:prstGeom prst="rect">
+            <a:avLst/>
+          </a:prstGeom>
+          <a:noFill/>
+        </p:spPr>
+        <p:txBody>
+          <a:bodyPr wrap="square">
+            <a:spAutoFit/>
+          </a:bodyPr>
+          <a:lstStyle/>
+          <a:p>
+            <a:pPr algn="l"/>
+            <a:r>
+              <a:rPr sz="2800" b="1">
+                <a:solidFill>
+                  <a:srgbClr val="C4A15A"/>
+                </a:solidFill>
+                <a:latin typeface="Georgia"/>
+              </a:rPr>
+              <a:t>1</a:t>
+            </a:r>
+          </a:p>
+        </p:txBody>
+      </p:sp>
+      <p:sp>
+        <p:nvSpPr>
+          <p:cNvPr id="8" name="TextBox 7"/>
+          <p:cNvSpPr txBox="1"/>
+          <p:nvPr/>
+        </p:nvSpPr>
+        <p:spPr>
+          <a:xfrm>
+            <a:off x="1463040" y="1719072"/>
+            <a:ext cx="9601200" cy="411480"/>
+          </a:xfrm>
+          <a:prstGeom prst="rect">
+            <a:avLst/>
+          </a:prstGeom>
+          <a:noFill/>
+        </p:spPr>
+        <p:txBody>
+          <a:bodyPr wrap="square">
+            <a:spAutoFit/>
+          </a:bodyPr>
+          <a:lstStyle/>
+          <a:p>
+            <a:pPr algn="l"/>
+            <a:r>
+              <a:rPr sz="2200" b="1">
+                <a:solidFill>
+                  <a:srgbClr val="12243F"/>
+                </a:solidFill>
+                <a:latin typeface="Georgia"/>
+              </a:rPr>
+              <a:t>The sample opens</a:t>
+            </a:r>
+          </a:p>
+        </p:txBody>
+      </p:sp>
+      <p:sp>
+        <p:nvSpPr>
+          <p:cNvPr id="9" name="TextBox 8"/>
+          <p:cNvSpPr txBox="1"/>
+          <p:nvPr/>
+        </p:nvSpPr>
+        <p:spPr>
+          <a:xfrm>
+            <a:off x="1463040" y="2176272"/>
+            <a:ext cx="9601200" cy="365760"/>
+          </a:xfrm>
+          <a:prstGeom prst="rect">
+            <a:avLst/>
+          </a:prstGeom>
+          <a:noFill/>
+        </p:spPr>
+        <p:txBody>
+          <a:bodyPr wrap="square">
+            <a:spAutoFit/>
+          </a:bodyPr>
+          <a:lstStyle/>
+          <a:p>
+            <a:pPr algn="l"/>
+            <a:r>
+              <a:rPr sz="1600" b="0">
+                <a:solidFill>
+                  <a:srgbClr val="1B2416"/>
+                </a:solidFill>
+                <a:latin typeface="Calibri"/>
+              </a:rPr>
+              <a:t>demo --serve shows Morning, Important, Informational, and Reference.</a:t>
+            </a:r>
+          </a:p>
+        </p:txBody>
+      </p:sp>
+      <p:sp>
+        <p:nvSpPr>
+          <p:cNvPr id="10" name="Rectangle 9"/>
+          <p:cNvSpPr/>
+          <p:nvPr/>
+        </p:nvSpPr>
+        <p:spPr>
+          <a:xfrm>
+            <a:off x="502920" y="2880360"/>
+            <a:ext cx="11155680" cy="1188720"/>
+          </a:xfrm>
+          <a:prstGeom prst="rect">
+            <a:avLst/>
+          </a:prstGeom>
+          <a:solidFill>
+            <a:srgbClr val="FFFCF7"/>
+          </a:solidFill>
+          <a:ln>
+            <a:noFill/>
+          </a:ln>
+        </p:spPr>
+        <p:style>
+          <a:lnRef idx="1">
+            <a:schemeClr val="accent1"/>
+          </a:lnRef>
+          <a:fillRef idx="3">
+            <a:schemeClr val="accent1"/>
+          </a:fillRef>
+          <a:effectRef idx="2">
+            <a:schemeClr val="accent1"/>
+          </a:effectRef>
+          <a:fontRef idx="minor">
+            <a:schemeClr val="lt1"/>
+          </a:fontRef>
+        </p:style>
+        <p:txBody>
+          <a:bodyPr rtlCol="0" anchor="ctr"/>
+          <a:lstStyle/>
+          <a:p>
+            <a:pPr algn="ctr"/>
+          </a:p>
+        </p:txBody>
+      </p:sp>
+      <p:sp>
+        <p:nvSpPr>
+          <p:cNvPr id="11" name="TextBox 10"/>
+          <p:cNvSpPr txBox="1"/>
+          <p:nvPr/>
+        </p:nvSpPr>
+        <p:spPr>
+          <a:xfrm>
+            <a:off x="685800" y="3136392"/>
+            <a:ext cx="640080" cy="640080"/>
+          </a:xfrm>
+          <a:prstGeom prst="rect">
+            <a:avLst/>
+          </a:prstGeom>
+          <a:noFill/>
+        </p:spPr>
+        <p:txBody>
+          <a:bodyPr wrap="square">
+            <a:spAutoFit/>
+          </a:bodyPr>
+          <a:lstStyle/>
+          <a:p>
+            <a:pPr algn="l"/>
+            <a:r>
+              <a:rPr sz="2800" b="1">
+                <a:solidFill>
+                  <a:srgbClr val="C4A15A"/>
+                </a:solidFill>
+                <a:latin typeface="Georgia"/>
+              </a:rPr>
+              <a:t>2</a:t>
+            </a:r>
+          </a:p>
+        </p:txBody>
+      </p:sp>
+      <p:sp>
+        <p:nvSpPr>
+          <p:cNvPr id="12" name="TextBox 11"/>
+          <p:cNvSpPr txBox="1"/>
+          <p:nvPr/>
+        </p:nvSpPr>
+        <p:spPr>
+          <a:xfrm>
+            <a:off x="1463040" y="3044952"/>
+            <a:ext cx="9601200" cy="411480"/>
+          </a:xfrm>
+          <a:prstGeom prst="rect">
+            <a:avLst/>
+          </a:prstGeom>
+          <a:noFill/>
+        </p:spPr>
+        <p:txBody>
+          <a:bodyPr wrap="square">
+            <a:spAutoFit/>
+          </a:bodyPr>
+          <a:lstStyle/>
+          <a:p>
+            <a:pPr algn="l"/>
+            <a:r>
+              <a:rPr sz="2200" b="1">
+                <a:solidFill>
+                  <a:srgbClr val="12243F"/>
+                </a:solidFill>
+                <a:latin typeface="Georgia"/>
+              </a:rPr>
+              <a:t>Your file lands</a:t>
+            </a:r>
+          </a:p>
+        </p:txBody>
+      </p:sp>
+      <p:sp>
+        <p:nvSpPr>
+          <p:cNvPr id="13" name="TextBox 12"/>
+          <p:cNvSpPr txBox="1"/>
+          <p:nvPr/>
+        </p:nvSpPr>
+        <p:spPr>
+          <a:xfrm>
+            <a:off x="1463040" y="3502152"/>
+            <a:ext cx="9601200" cy="365760"/>
+          </a:xfrm>
+          <a:prstGeom prst="rect">
+            <a:avLst/>
+          </a:prstGeom>
+          <a:noFill/>
+        </p:spPr>
+        <p:txBody>
+          <a:bodyPr wrap="square">
+            <a:spAutoFit/>
+          </a:bodyPr>
+          <a:lstStyle/>
+          <a:p>
+            <a:pPr algn="l"/>
+            <a:r>
+              <a:rPr sz="1600" b="0">
+                <a:solidFill>
+                  <a:srgbClr val="1B2416"/>
+                </a:solidFill>
+                <a:latin typeface="Calibri"/>
+              </a:rPr>
+              <a:t>A .msg in inbox/incoming shows up after ingest or overnight.</a:t>
+            </a:r>
+          </a:p>
+        </p:txBody>
+      </p:sp>
+      <p:sp>
+        <p:nvSpPr>
+          <p:cNvPr id="14" name="Rectangle 13"/>
+          <p:cNvSpPr/>
+          <p:nvPr/>
+        </p:nvSpPr>
+        <p:spPr>
+          <a:xfrm>
+            <a:off x="502920" y="4206240"/>
+            <a:ext cx="11155680" cy="1188720"/>
+          </a:xfrm>
+          <a:prstGeom prst="rect">
+            <a:avLst/>
+          </a:prstGeom>
+          <a:solidFill>
+            <a:srgbClr val="FFFCF7"/>
+          </a:solidFill>
+          <a:ln>
+            <a:noFill/>
+          </a:ln>
+        </p:spPr>
+        <p:style>
+          <a:lnRef idx="1">
+            <a:schemeClr val="accent1"/>
+          </a:lnRef>
+          <a:fillRef idx="3">
+            <a:schemeClr val="accent1"/>
+          </a:fillRef>
+          <a:effectRef idx="2">
+            <a:schemeClr val="accent1"/>
+          </a:effectRef>
+          <a:fontRef idx="minor">
+            <a:schemeClr val="lt1"/>
+          </a:fontRef>
+        </p:style>
+        <p:txBody>
+          <a:bodyPr rtlCol="0" anchor="ctr"/>
+          <a:lstStyle/>
+          <a:p>
+            <a:pPr algn="ctr"/>
+          </a:p>
+        </p:txBody>
+      </p:sp>
+      <p:sp>
+        <p:nvSpPr>
+          <p:cNvPr id="15" name="TextBox 14"/>
+          <p:cNvSpPr txBox="1"/>
+          <p:nvPr/>
+        </p:nvSpPr>
+        <p:spPr>
+          <a:xfrm>
+            <a:off x="685800" y="4462272"/>
+            <a:ext cx="640080" cy="640080"/>
+          </a:xfrm>
+          <a:prstGeom prst="rect">
+            <a:avLst/>
+          </a:prstGeom>
+          <a:noFill/>
+        </p:spPr>
+        <p:txBody>
+          <a:bodyPr wrap="square">
+            <a:spAutoFit/>
+          </a:bodyPr>
+          <a:lstStyle/>
+          <a:p>
+            <a:pPr algn="l"/>
+            <a:r>
+              <a:rPr sz="2800" b="1">
+                <a:solidFill>
+                  <a:srgbClr val="C4A15A"/>
+                </a:solidFill>
+                <a:latin typeface="Georgia"/>
+              </a:rPr>
+              <a:t>3</a:t>
+            </a:r>
+          </a:p>
+        </p:txBody>
+      </p:sp>
+      <p:sp>
+        <p:nvSpPr>
+          <p:cNvPr id="16" name="TextBox 15"/>
+          <p:cNvSpPr txBox="1"/>
+          <p:nvPr/>
+        </p:nvSpPr>
+        <p:spPr>
+          <a:xfrm>
+            <a:off x="1463040" y="4370832"/>
+            <a:ext cx="9601200" cy="411480"/>
+          </a:xfrm>
+          <a:prstGeom prst="rect">
+            <a:avLst/>
+          </a:prstGeom>
+          <a:noFill/>
+        </p:spPr>
+        <p:txBody>
+          <a:bodyPr wrap="square">
+            <a:spAutoFit/>
+          </a:bodyPr>
+          <a:lstStyle/>
+          <a:p>
+            <a:pPr algn="l"/>
+            <a:r>
+              <a:rPr sz="2200" b="1">
+                <a:solidFill>
+                  <a:srgbClr val="12243F"/>
+                </a:solidFill>
+                <a:latin typeface="Georgia"/>
+              </a:rPr>
+              <a:t>Bionic reads</a:t>
+            </a:r>
+          </a:p>
+        </p:txBody>
+      </p:sp>
+      <p:sp>
+        <p:nvSpPr>
+          <p:cNvPr id="17" name="TextBox 16"/>
+          <p:cNvSpPr txBox="1"/>
+          <p:nvPr/>
+        </p:nvSpPr>
+        <p:spPr>
+          <a:xfrm>
+            <a:off x="1463040" y="4828032"/>
+            <a:ext cx="9601200" cy="365760"/>
+          </a:xfrm>
+          <a:prstGeom prst="rect">
+            <a:avLst/>
+          </a:prstGeom>
+          <a:noFill/>
+        </p:spPr>
+        <p:txBody>
+          <a:bodyPr wrap="square">
+            <a:spAutoFit/>
+          </a:bodyPr>
+          <a:lstStyle/>
+          <a:p>
+            <a:pPr algn="l"/>
+            <a:r>
+              <a:rPr sz="1600" b="0">
+                <a:solidFill>
+                  <a:srgbClr val="1B2416"/>
+                </a:solidFill>
+                <a:latin typeface="Calibri"/>
+              </a:rPr>
+              <a:t>With the LM Studio server on, rows can say Read by Bionic.</a:t>
+            </a:r>
+          </a:p>
+        </p:txBody>
+      </p:sp>
+      <p:sp>
+        <p:nvSpPr>
+          <p:cNvPr id="18" name="TextBox 17"/>
+          <p:cNvSpPr txBox="1"/>
+          <p:nvPr/>
+        </p:nvSpPr>
+        <p:spPr>
+          <a:xfrm>
+            <a:off x="502920" y="6446520"/>
+            <a:ext cx="8229600" cy="274320"/>
+          </a:xfrm>
+          <a:prstGeom prst="rect">
+            <a:avLst/>
+          </a:prstGeom>
+          <a:noFill/>
+        </p:spPr>
+        <p:txBody>
+          <a:bodyPr wrap="square">
+            <a:spAutoFit/>
+          </a:bodyPr>
+          <a:lstStyle/>
+          <a:p>
+            <a:pPr algn="l"/>
+            <a:r>
+              <a:rPr sz="1100" b="0">
+                <a:solidFill>
+                  <a:srgbClr val="5E6A59"/>
+                </a:solidFill>
+                <a:latin typeface="Calibri"/>
+              </a:rPr>
+              <a:t>CloseDesk  ·  scripts extract, Bionic decides</a:t>
+            </a:r>
+          </a:p>
+        </p:txBody>
+      </p:sp>
+      <p:sp>
+        <p:nvSpPr>
+          <p:cNvPr id="19" name="TextBox 18"/>
+          <p:cNvSpPr txBox="1"/>
+          <p:nvPr/>
+        </p:nvSpPr>
+        <p:spPr>
+          <a:xfrm>
+            <a:off x="10424160" y="6446520"/>
+            <a:ext cx="1280160" cy="274320"/>
+          </a:xfrm>
+          <a:prstGeom prst="rect">
+            <a:avLst/>
+          </a:prstGeom>
+          <a:noFill/>
+        </p:spPr>
+        <p:txBody>
+          <a:bodyPr wrap="square">
+            <a:spAutoFit/>
+          </a:bodyPr>
+          <a:lstStyle/>
+          <a:p>
+            <a:pPr algn="r"/>
+            <a:r>
+              <a:rPr sz="1100" b="0">
+                <a:solidFill>
+                  <a:srgbClr val="5E6A59"/>
+                </a:solidFill>
+                <a:latin typeface="Calibri"/>
+              </a:rPr>
+              <a:t>13  /  13</a:t>
             </a:r>
           </a:p>
         </p:txBody>
@@ -4903,7 +5592,7 @@
                 </a:solidFill>
                 <a:latin typeface="Calibri"/>
               </a:rPr>
-              <a:t>2  /  12</a:t>
+              <a:t>2  /  13</a:t>
             </a:r>
           </a:p>
         </p:txBody>
@@ -5477,7 +6166,7 @@
                 </a:solidFill>
                 <a:latin typeface="Calibri"/>
               </a:rPr>
-              <a:t>3  /  12</a:t>
+              <a:t>3  /  13</a:t>
             </a:r>
           </a:p>
         </p:txBody>
@@ -6173,7 +6862,7 @@
                 </a:solidFill>
                 <a:latin typeface="Calibri"/>
               </a:rPr>
-              <a:t>4  /  12</a:t>
+              <a:t>4  /  13</a:t>
             </a:r>
           </a:p>
         </p:txBody>
@@ -7095,7 +7784,7 @@
                 </a:solidFill>
                 <a:latin typeface="Calibri"/>
               </a:rPr>
-              <a:t>5  /  12</a:t>
+              <a:t>5  /  13</a:t>
             </a:r>
           </a:p>
         </p:txBody>
@@ -7904,7 +8593,7 @@
                 </a:solidFill>
                 <a:latin typeface="Calibri"/>
               </a:rPr>
-              <a:t>6  /  12</a:t>
+              <a:t>6  /  13</a:t>
             </a:r>
           </a:p>
         </p:txBody>
@@ -8487,7 +9176,7 @@
                 </a:solidFill>
                 <a:latin typeface="Georgia"/>
               </a:rPr>
-              <a:t>Read</a:t>
+              <a:t>File</a:t>
             </a:r>
           </a:p>
         </p:txBody>
@@ -8775,7 +9464,7 @@
                 </a:solidFill>
                 <a:latin typeface="Calibri"/>
               </a:rPr>
-              <a:t>7  /  12</a:t>
+              <a:t>7  /  13</a:t>
             </a:r>
           </a:p>
         </p:txBody>
@@ -9349,7 +10038,7 @@
                 </a:solidFill>
                 <a:latin typeface="Calibri"/>
               </a:rPr>
-              <a:t>8  /  12</a:t>
+              <a:t>8  /  13</a:t>
             </a:r>
           </a:p>
         </p:txBody>
@@ -9712,7 +10401,7 @@
                 </a:solidFill>
                 <a:latin typeface="Calibri"/>
               </a:rPr>
-              <a:t>9  /  12</a:t>
+              <a:t>9  /  13</a:t>
             </a:r>
           </a:p>
         </p:txBody>

</xml_diff>